<commit_message>
Ganti istilah "peramban" menjadi "browser" di seluruh manual dan slide
Termasuk mengganti nama berkas M6 agar konsisten dengan judulnya.

Co-Authored-By: Claude Sonnet 5 <noreply@anthropic.com>
</commit_message>
<xml_diff>
--- a/slide/Pelatihan-GitHub-IDTC-Sesi1.pptx
+++ b/slide/Pelatihan-GitHub-IDTC-Sesi1.pptx
@@ -2315,7 +2315,7 @@
                 <a:ea typeface="Calibri" pitchFamily="34" charset="-122"/>
                 <a:cs typeface="Calibri" pitchFamily="34" charset="-120"/>
               </a:rPr>
-              <a:t>Tidak perlu kemampuan pemrograman — seluruh materi dikerjakan lewat peramban.</a:t>
+              <a:t>Tidak perlu kemampuan pemrograman — seluruh materi dikerjakan lewat browser.</a:t>
             </a:r>
             <a:endParaRPr lang="en-US" sz="1300" dirty="0"/>
           </a:p>
@@ -7362,7 +7362,7 @@
                 <a:ea typeface="Calibri" pitchFamily="34" charset="-122"/>
                 <a:cs typeface="Calibri" pitchFamily="34" charset="-120"/>
               </a:rPr>
-              <a:t>Mengira harus memasang aplikasi dulu — tegaskan semua lewat peramban</a:t>
+              <a:t>Mengira harus memasang aplikasi dulu — tegaskan semua lewat browser</a:t>
             </a:r>
             <a:endParaRPr lang="en-US" sz="1250" dirty="0"/>
           </a:p>

</xml_diff>